<commit_message>
added InkPath QR code to slides
</commit_message>
<xml_diff>
--- a/Python_intro_slides.pptx
+++ b/Python_intro_slides.pptx
@@ -5,7 +5,7 @@
     <p:sldMasterId id="2147483648" r:id="rId1"/>
   </p:sldMasterIdLst>
   <p:notesMasterIdLst>
-    <p:notesMasterId r:id="rId22"/>
+    <p:notesMasterId r:id="rId23"/>
   </p:notesMasterIdLst>
   <p:sldIdLst>
     <p:sldId id="264" r:id="rId2"/>
@@ -28,6 +28,7 @@
     <p:sldId id="284" r:id="rId19"/>
     <p:sldId id="375" r:id="rId20"/>
     <p:sldId id="376" r:id="rId21"/>
+    <p:sldId id="380" r:id="rId22"/>
   </p:sldIdLst>
   <p:sldSz cx="12192000" cy="6858000"/>
   <p:notesSz cx="6858000" cy="9144000"/>
@@ -756,7 +757,7 @@
           <a:p>
             <a:fld id="{03C9BEE4-7396-45A3-B049-3FF4E62023A5}" type="datetimeFigureOut">
               <a:rPr lang="en-DE" smtClean="0"/>
-              <a:t>05/02/2026</a:t>
+              <a:t>18/02/2026</a:t>
             </a:fld>
             <a:endParaRPr lang="en-DE"/>
           </a:p>
@@ -2595,7 +2596,7 @@
           <a:p>
             <a:fld id="{0A210ACD-79C8-41FF-A78C-1E87BB77729C}" type="datetimeFigureOut">
               <a:rPr lang="en-DE" smtClean="0"/>
-              <a:t>05/02/2026</a:t>
+              <a:t>18/02/2026</a:t>
             </a:fld>
             <a:endParaRPr lang="en-DE"/>
           </a:p>
@@ -2795,7 +2796,7 @@
           <a:p>
             <a:fld id="{0A210ACD-79C8-41FF-A78C-1E87BB77729C}" type="datetimeFigureOut">
               <a:rPr lang="en-DE" smtClean="0"/>
-              <a:t>05/02/2026</a:t>
+              <a:t>18/02/2026</a:t>
             </a:fld>
             <a:endParaRPr lang="en-DE"/>
           </a:p>
@@ -3005,7 +3006,7 @@
           <a:p>
             <a:fld id="{0A210ACD-79C8-41FF-A78C-1E87BB77729C}" type="datetimeFigureOut">
               <a:rPr lang="en-DE" smtClean="0"/>
-              <a:t>05/02/2026</a:t>
+              <a:t>18/02/2026</a:t>
             </a:fld>
             <a:endParaRPr lang="en-DE"/>
           </a:p>
@@ -3205,7 +3206,7 @@
           <a:p>
             <a:fld id="{0A210ACD-79C8-41FF-A78C-1E87BB77729C}" type="datetimeFigureOut">
               <a:rPr lang="en-DE" smtClean="0"/>
-              <a:t>05/02/2026</a:t>
+              <a:t>18/02/2026</a:t>
             </a:fld>
             <a:endParaRPr lang="en-DE"/>
           </a:p>
@@ -3481,7 +3482,7 @@
           <a:p>
             <a:fld id="{0A210ACD-79C8-41FF-A78C-1E87BB77729C}" type="datetimeFigureOut">
               <a:rPr lang="en-DE" smtClean="0"/>
-              <a:t>05/02/2026</a:t>
+              <a:t>18/02/2026</a:t>
             </a:fld>
             <a:endParaRPr lang="en-DE"/>
           </a:p>
@@ -3749,7 +3750,7 @@
           <a:p>
             <a:fld id="{0A210ACD-79C8-41FF-A78C-1E87BB77729C}" type="datetimeFigureOut">
               <a:rPr lang="en-DE" smtClean="0"/>
-              <a:t>05/02/2026</a:t>
+              <a:t>18/02/2026</a:t>
             </a:fld>
             <a:endParaRPr lang="en-DE"/>
           </a:p>
@@ -4164,7 +4165,7 @@
           <a:p>
             <a:fld id="{0A210ACD-79C8-41FF-A78C-1E87BB77729C}" type="datetimeFigureOut">
               <a:rPr lang="en-DE" smtClean="0"/>
-              <a:t>05/02/2026</a:t>
+              <a:t>18/02/2026</a:t>
             </a:fld>
             <a:endParaRPr lang="en-DE"/>
           </a:p>
@@ -4306,7 +4307,7 @@
           <a:p>
             <a:fld id="{0A210ACD-79C8-41FF-A78C-1E87BB77729C}" type="datetimeFigureOut">
               <a:rPr lang="en-DE" smtClean="0"/>
-              <a:t>05/02/2026</a:t>
+              <a:t>18/02/2026</a:t>
             </a:fld>
             <a:endParaRPr lang="en-DE"/>
           </a:p>
@@ -4419,7 +4420,7 @@
           <a:p>
             <a:fld id="{0A210ACD-79C8-41FF-A78C-1E87BB77729C}" type="datetimeFigureOut">
               <a:rPr lang="en-DE" smtClean="0"/>
-              <a:t>05/02/2026</a:t>
+              <a:t>18/02/2026</a:t>
             </a:fld>
             <a:endParaRPr lang="en-DE"/>
           </a:p>
@@ -4732,7 +4733,7 @@
           <a:p>
             <a:fld id="{0A210ACD-79C8-41FF-A78C-1E87BB77729C}" type="datetimeFigureOut">
               <a:rPr lang="en-DE" smtClean="0"/>
-              <a:t>05/02/2026</a:t>
+              <a:t>18/02/2026</a:t>
             </a:fld>
             <a:endParaRPr lang="en-DE"/>
           </a:p>
@@ -5021,7 +5022,7 @@
           <a:p>
             <a:fld id="{0A210ACD-79C8-41FF-A78C-1E87BB77729C}" type="datetimeFigureOut">
               <a:rPr lang="en-DE" smtClean="0"/>
-              <a:t>05/02/2026</a:t>
+              <a:t>18/02/2026</a:t>
             </a:fld>
             <a:endParaRPr lang="en-DE"/>
           </a:p>
@@ -5264,7 +5265,7 @@
           <a:p>
             <a:fld id="{0A210ACD-79C8-41FF-A78C-1E87BB77729C}" type="datetimeFigureOut">
               <a:rPr lang="en-DE" smtClean="0"/>
-              <a:t>05/02/2026</a:t>
+              <a:t>18/02/2026</a:t>
             </a:fld>
             <a:endParaRPr lang="en-DE"/>
           </a:p>
@@ -11590,6 +11591,66 @@
     <p:extLst>
       <p:ext uri="{BB962C8B-B14F-4D97-AF65-F5344CB8AC3E}">
         <p14:creationId xmlns:p14="http://schemas.microsoft.com/office/powerpoint/2010/main" val="3564412488"/>
+      </p:ext>
+    </p:extLst>
+  </p:cSld>
+  <p:clrMapOvr>
+    <a:masterClrMapping/>
+  </p:clrMapOvr>
+</p:sld>
+</file>
+
+<file path=ppt/slides/slide21.xml><?xml version="1.0" encoding="utf-8"?>
+<p:sld xmlns:a="http://schemas.openxmlformats.org/drawingml/2006/main" xmlns:r="http://schemas.openxmlformats.org/officeDocument/2006/relationships" xmlns:p="http://schemas.openxmlformats.org/presentationml/2006/main">
+  <p:cSld>
+    <p:spTree>
+      <p:nvGrpSpPr>
+        <p:cNvPr id="1" name=""/>
+        <p:cNvGrpSpPr/>
+        <p:nvPr/>
+      </p:nvGrpSpPr>
+      <p:grpSpPr>
+        <a:xfrm>
+          <a:off x="0" y="0"/>
+          <a:ext cx="0" cy="0"/>
+          <a:chOff x="0" y="0"/>
+          <a:chExt cx="0" cy="0"/>
+        </a:xfrm>
+      </p:grpSpPr>
+      <p:pic>
+        <p:nvPicPr>
+          <p:cNvPr id="3" name="Picture 2">
+            <a:extLst>
+              <a:ext uri="{FF2B5EF4-FFF2-40B4-BE49-F238E27FC236}">
+                <a16:creationId xmlns:a16="http://schemas.microsoft.com/office/drawing/2014/main" id="{AB1EF50C-6C29-B0F4-BBFB-9AF2A66F4890}"/>
+              </a:ext>
+            </a:extLst>
+          </p:cNvPr>
+          <p:cNvPicPr>
+            <a:picLocks noChangeAspect="1"/>
+          </p:cNvPicPr>
+          <p:nvPr/>
+        </p:nvPicPr>
+        <p:blipFill>
+          <a:blip r:embed="rId2"/>
+          <a:stretch>
+            <a:fillRect/>
+          </a:stretch>
+        </p:blipFill>
+        <p:spPr>
+          <a:xfrm>
+            <a:off x="889334" y="0"/>
+            <a:ext cx="10413332" cy="6858000"/>
+          </a:xfrm>
+          <a:prstGeom prst="rect">
+            <a:avLst/>
+          </a:prstGeom>
+        </p:spPr>
+      </p:pic>
+    </p:spTree>
+    <p:extLst>
+      <p:ext uri="{BB962C8B-B14F-4D97-AF65-F5344CB8AC3E}">
+        <p14:creationId xmlns:p14="http://schemas.microsoft.com/office/powerpoint/2010/main" val="1717462397"/>
       </p:ext>
     </p:extLst>
   </p:cSld>

</xml_diff>

<commit_message>
removed the InkPath QR code following live session
</commit_message>
<xml_diff>
--- a/Python_intro_slides.pptx
+++ b/Python_intro_slides.pptx
@@ -5,7 +5,7 @@
     <p:sldMasterId id="2147483648" r:id="rId1"/>
   </p:sldMasterIdLst>
   <p:notesMasterIdLst>
-    <p:notesMasterId r:id="rId23"/>
+    <p:notesMasterId r:id="rId22"/>
   </p:notesMasterIdLst>
   <p:sldIdLst>
     <p:sldId id="264" r:id="rId2"/>
@@ -28,7 +28,6 @@
     <p:sldId id="284" r:id="rId19"/>
     <p:sldId id="375" r:id="rId20"/>
     <p:sldId id="376" r:id="rId21"/>
-    <p:sldId id="380" r:id="rId22"/>
   </p:sldIdLst>
   <p:sldSz cx="12192000" cy="6858000"/>
   <p:notesSz cx="6858000" cy="9144000"/>
@@ -11591,66 +11590,6 @@
     <p:extLst>
       <p:ext uri="{BB962C8B-B14F-4D97-AF65-F5344CB8AC3E}">
         <p14:creationId xmlns:p14="http://schemas.microsoft.com/office/powerpoint/2010/main" val="3564412488"/>
-      </p:ext>
-    </p:extLst>
-  </p:cSld>
-  <p:clrMapOvr>
-    <a:masterClrMapping/>
-  </p:clrMapOvr>
-</p:sld>
-</file>
-
-<file path=ppt/slides/slide21.xml><?xml version="1.0" encoding="utf-8"?>
-<p:sld xmlns:a="http://schemas.openxmlformats.org/drawingml/2006/main" xmlns:r="http://schemas.openxmlformats.org/officeDocument/2006/relationships" xmlns:p="http://schemas.openxmlformats.org/presentationml/2006/main">
-  <p:cSld>
-    <p:spTree>
-      <p:nvGrpSpPr>
-        <p:cNvPr id="1" name=""/>
-        <p:cNvGrpSpPr/>
-        <p:nvPr/>
-      </p:nvGrpSpPr>
-      <p:grpSpPr>
-        <a:xfrm>
-          <a:off x="0" y="0"/>
-          <a:ext cx="0" cy="0"/>
-          <a:chOff x="0" y="0"/>
-          <a:chExt cx="0" cy="0"/>
-        </a:xfrm>
-      </p:grpSpPr>
-      <p:pic>
-        <p:nvPicPr>
-          <p:cNvPr id="3" name="Picture 2">
-            <a:extLst>
-              <a:ext uri="{FF2B5EF4-FFF2-40B4-BE49-F238E27FC236}">
-                <a16:creationId xmlns:a16="http://schemas.microsoft.com/office/drawing/2014/main" id="{AB1EF50C-6C29-B0F4-BBFB-9AF2A66F4890}"/>
-              </a:ext>
-            </a:extLst>
-          </p:cNvPr>
-          <p:cNvPicPr>
-            <a:picLocks noChangeAspect="1"/>
-          </p:cNvPicPr>
-          <p:nvPr/>
-        </p:nvPicPr>
-        <p:blipFill>
-          <a:blip r:embed="rId2"/>
-          <a:stretch>
-            <a:fillRect/>
-          </a:stretch>
-        </p:blipFill>
-        <p:spPr>
-          <a:xfrm>
-            <a:off x="889334" y="0"/>
-            <a:ext cx="10413332" cy="6858000"/>
-          </a:xfrm>
-          <a:prstGeom prst="rect">
-            <a:avLst/>
-          </a:prstGeom>
-        </p:spPr>
-      </p:pic>
-    </p:spTree>
-    <p:extLst>
-      <p:ext uri="{BB962C8B-B14F-4D97-AF65-F5344CB8AC3E}">
-        <p14:creationId xmlns:p14="http://schemas.microsoft.com/office/powerpoint/2010/main" val="1717462397"/>
       </p:ext>
     </p:extLst>
   </p:cSld>

</xml_diff>